<commit_message>
Add M-Trace challenge questions slide
Co-authored-by: Copilot <223556219+Copilot@users.noreply.github.com>
</commit_message>
<xml_diff>
--- a/docs/M-Trace_Technology_Candidate_Presentation_TraceID_Architecture.pptx
+++ b/docs/M-Trace_Technology_Candidate_Presentation_TraceID_Architecture.pptx
@@ -15,6 +15,7 @@
     <p:sldId id="261" r:id="rId8"/>
     <p:sldId id="263" r:id="rId9"/>
     <p:sldId id="264" r:id="rId10"/>
+    <p:sldId id="267" r:id="rId16"/>
   </p:sldIdLst>
   <p:sldSz cx="12192000" cy="6858000"/>
   <p:notesSz cx="6858000" cy="9144000"/>
@@ -5243,6 +5244,1858 @@
                 <a:latin typeface="Malgun Gothic"/>
               </a:rPr>
               <a:t>상세화할 사항: 입력 필드·데이터 흐름·판단 조건·예외 처리·기존 기술 대비 차이.</a:t>
+            </a:r>
+          </a:p>
+        </p:txBody>
+      </p:sp>
+    </p:spTree>
+  </p:cSld>
+  <p:clrMapOvr>
+    <a:masterClrMapping/>
+  </p:clrMapOvr>
+</p:sld>
+</file>
+
+<file path=ppt/slides/slide11.xml><?xml version="1.0" encoding="utf-8"?>
+<p:sld xmlns:a="http://schemas.openxmlformats.org/drawingml/2006/main" xmlns:p="http://schemas.openxmlformats.org/presentationml/2006/main" xmlns:r="http://schemas.openxmlformats.org/officeDocument/2006/relationships">
+  <p:cSld>
+    <p:bg>
+      <p:bgPr>
+        <a:solidFill>
+          <a:srgbClr val="0B1020"/>
+        </a:solidFill>
+        <a:effectLst/>
+      </p:bgPr>
+    </p:bg>
+    <p:spTree>
+      <p:nvGrpSpPr>
+        <p:cNvPr id="1" name=""/>
+        <p:cNvGrpSpPr/>
+        <p:nvPr/>
+      </p:nvGrpSpPr>
+      <p:grpSpPr/>
+      <p:sp>
+        <p:nvSpPr>
+          <p:cNvPr id="2" name="TextBox 1"/>
+          <p:cNvSpPr txBox="1"/>
+          <p:nvPr/>
+        </p:nvSpPr>
+        <p:spPr>
+          <a:xfrm>
+            <a:off x="585216" y="246888"/>
+            <a:ext cx="10789920" cy="246888"/>
+          </a:xfrm>
+          <a:prstGeom prst="rect">
+            <a:avLst/>
+          </a:prstGeom>
+          <a:noFill/>
+        </p:spPr>
+        <p:txBody>
+          <a:bodyPr wrap="square" anchor="ctr" lIns="18288" rIns="18288" tIns="9144" bIns="9144">
+            <a:spAutoFit/>
+          </a:bodyPr>
+          <a:lstStyle/>
+          <a:p>
+            <a:pPr algn="l">
+              <a:spcBef>
+                <a:spcPts val="0"/>
+              </a:spcBef>
+              <a:spcAft>
+                <a:spcPts val="0"/>
+              </a:spcAft>
+            </a:pPr>
+            <a:r>
+              <a:rPr sz="1000" b="1">
+                <a:solidFill>
+                  <a:srgbClr val="42D6C1"/>
+                </a:solidFill>
+                <a:latin typeface="Malgun Gothic"/>
+              </a:rPr>
+              <a:t>M-Trace  ·  예상 질문과 검증 과제</a:t>
+            </a:r>
+          </a:p>
+        </p:txBody>
+      </p:sp>
+      <p:sp>
+        <p:nvSpPr>
+          <p:cNvPr id="3" name="TextBox 2"/>
+          <p:cNvSpPr txBox="1"/>
+          <p:nvPr/>
+        </p:nvSpPr>
+        <p:spPr>
+          <a:xfrm>
+            <a:off x="585216" y="594360"/>
+            <a:ext cx="10972800" cy="548640"/>
+          </a:xfrm>
+          <a:prstGeom prst="rect">
+            <a:avLst/>
+          </a:prstGeom>
+          <a:noFill/>
+        </p:spPr>
+        <p:txBody>
+          <a:bodyPr wrap="square" anchor="ctr" lIns="18288" rIns="18288" tIns="9144" bIns="9144">
+            <a:spAutoFit/>
+          </a:bodyPr>
+          <a:lstStyle/>
+          <a:p>
+            <a:pPr algn="l">
+              <a:spcBef>
+                <a:spcPts val="0"/>
+              </a:spcBef>
+              <a:spcAft>
+                <a:spcPts val="0"/>
+              </a:spcAft>
+            </a:pPr>
+            <a:r>
+              <a:rPr sz="2500" b="1">
+                <a:solidFill>
+                  <a:srgbClr val="F3F6FC"/>
+                </a:solidFill>
+                <a:latin typeface="Malgun Gothic"/>
+              </a:rPr>
+              <a:t>M-Trace가 답해야 할 9가지 챌린지</a:t>
+            </a:r>
+          </a:p>
+        </p:txBody>
+      </p:sp>
+      <p:sp>
+        <p:nvSpPr>
+          <p:cNvPr id="4" name="Rectangle 3"/>
+          <p:cNvSpPr/>
+          <p:nvPr/>
+        </p:nvSpPr>
+        <p:spPr>
+          <a:xfrm>
+            <a:off x="585216" y="1298448"/>
+            <a:ext cx="11009376" cy="10972"/>
+          </a:xfrm>
+          <a:prstGeom prst="rect">
+            <a:avLst/>
+          </a:prstGeom>
+          <a:solidFill>
+            <a:srgbClr val="2B3A55"/>
+          </a:solidFill>
+          <a:ln>
+            <a:noFill/>
+          </a:ln>
+        </p:spPr>
+        <p:style>
+          <a:lnRef idx="1">
+            <a:schemeClr val="accent1"/>
+          </a:lnRef>
+          <a:fillRef idx="3">
+            <a:schemeClr val="accent1"/>
+          </a:fillRef>
+          <a:effectRef idx="2">
+            <a:schemeClr val="accent1"/>
+          </a:effectRef>
+          <a:fontRef idx="minor">
+            <a:schemeClr val="lt1"/>
+          </a:fontRef>
+        </p:style>
+        <p:txBody>
+          <a:bodyPr rtlCol="0" anchor="ctr"/>
+          <a:lstStyle/>
+          <a:p>
+            <a:pPr algn="ctr"/>
+          </a:p>
+        </p:txBody>
+      </p:sp>
+      <p:sp>
+        <p:nvSpPr>
+          <p:cNvPr id="5" name="Rounded Rectangle 4"/>
+          <p:cNvSpPr/>
+          <p:nvPr/>
+        </p:nvSpPr>
+        <p:spPr>
+          <a:xfrm>
+            <a:off x="621792" y="1536192"/>
+            <a:ext cx="3456432" cy="1133856"/>
+          </a:xfrm>
+          <a:prstGeom prst="roundRect">
+            <a:avLst/>
+          </a:prstGeom>
+          <a:solidFill>
+            <a:srgbClr val="131D32"/>
+          </a:solidFill>
+          <a:ln>
+            <a:noFill/>
+          </a:ln>
+        </p:spPr>
+        <p:style>
+          <a:lnRef idx="1">
+            <a:schemeClr val="accent1"/>
+          </a:lnRef>
+          <a:fillRef idx="3">
+            <a:schemeClr val="accent1"/>
+          </a:fillRef>
+          <a:effectRef idx="2">
+            <a:schemeClr val="accent1"/>
+          </a:effectRef>
+          <a:fontRef idx="minor">
+            <a:schemeClr val="lt1"/>
+          </a:fontRef>
+        </p:style>
+        <p:txBody>
+          <a:bodyPr rtlCol="0" anchor="ctr"/>
+          <a:lstStyle/>
+          <a:p>
+            <a:pPr algn="ctr"/>
+          </a:p>
+        </p:txBody>
+      </p:sp>
+      <p:sp>
+        <p:nvSpPr>
+          <p:cNvPr id="6" name="Rectangle 5"/>
+          <p:cNvSpPr/>
+          <p:nvPr/>
+        </p:nvSpPr>
+        <p:spPr>
+          <a:xfrm>
+            <a:off x="621792" y="1600200"/>
+            <a:ext cx="50292" cy="1005840"/>
+          </a:xfrm>
+          <a:prstGeom prst="rect">
+            <a:avLst/>
+          </a:prstGeom>
+          <a:solidFill>
+            <a:srgbClr val="42D6C1"/>
+          </a:solidFill>
+          <a:ln>
+            <a:noFill/>
+          </a:ln>
+        </p:spPr>
+        <p:style>
+          <a:lnRef idx="1">
+            <a:schemeClr val="accent1"/>
+          </a:lnRef>
+          <a:fillRef idx="3">
+            <a:schemeClr val="accent1"/>
+          </a:fillRef>
+          <a:effectRef idx="2">
+            <a:schemeClr val="accent1"/>
+          </a:effectRef>
+          <a:fontRef idx="minor">
+            <a:schemeClr val="lt1"/>
+          </a:fontRef>
+        </p:style>
+        <p:txBody>
+          <a:bodyPr rtlCol="0" anchor="ctr"/>
+          <a:lstStyle/>
+          <a:p>
+            <a:pPr algn="ctr"/>
+          </a:p>
+        </p:txBody>
+      </p:sp>
+      <p:sp>
+        <p:nvSpPr>
+          <p:cNvPr id="7" name="TextBox 6"/>
+          <p:cNvSpPr txBox="1"/>
+          <p:nvPr/>
+        </p:nvSpPr>
+        <p:spPr>
+          <a:xfrm>
+            <a:off x="777240" y="1600200"/>
+            <a:ext cx="3163824" cy="292608"/>
+          </a:xfrm>
+          <a:prstGeom prst="rect">
+            <a:avLst/>
+          </a:prstGeom>
+          <a:noFill/>
+        </p:spPr>
+        <p:txBody>
+          <a:bodyPr wrap="square" anchor="ctr" lIns="18288" rIns="18288" tIns="9144" bIns="9144">
+            <a:spAutoFit/>
+          </a:bodyPr>
+          <a:lstStyle/>
+          <a:p>
+            <a:pPr algn="l">
+              <a:spcBef>
+                <a:spcPts val="0"/>
+              </a:spcBef>
+              <a:spcAft>
+                <a:spcPts val="0"/>
+              </a:spcAft>
+            </a:pPr>
+            <a:r>
+              <a:rPr sz="1200" b="1">
+                <a:solidFill>
+                  <a:srgbClr val="F3F6FC"/>
+                </a:solidFill>
+                <a:latin typeface="Malgun Gothic"/>
+              </a:rPr>
+              <a:t>01  데이터 규모·보존</a:t>
+            </a:r>
+          </a:p>
+        </p:txBody>
+      </p:sp>
+      <p:sp>
+        <p:nvSpPr>
+          <p:cNvPr id="8" name="TextBox 7"/>
+          <p:cNvSpPr txBox="1"/>
+          <p:nvPr/>
+        </p:nvSpPr>
+        <p:spPr>
+          <a:xfrm>
+            <a:off x="777240" y="1929384"/>
+            <a:ext cx="3163824" cy="621792"/>
+          </a:xfrm>
+          <a:prstGeom prst="rect">
+            <a:avLst/>
+          </a:prstGeom>
+          <a:noFill/>
+        </p:spPr>
+        <p:txBody>
+          <a:bodyPr wrap="square" anchor="ctr" lIns="18288" rIns="18288" tIns="9144" bIns="9144">
+            <a:spAutoFit/>
+          </a:bodyPr>
+          <a:lstStyle/>
+          <a:p>
+            <a:pPr algn="l">
+              <a:spcBef>
+                <a:spcPts val="0"/>
+              </a:spcBef>
+              <a:spcAft>
+                <a:spcPts val="0"/>
+              </a:spcAft>
+            </a:pPr>
+            <a:r>
+              <a:rPr sz="960" b="0">
+                <a:solidFill>
+                  <a:srgbClr val="AAB7CC"/>
+                </a:solidFill>
+                <a:latin typeface="Malgun Gothic"/>
+              </a:rPr>
+              <a:t>트랜잭션 수집 범위와 보존 기간, 저장·검색 비용은?</a:t>
+            </a:r>
+          </a:p>
+        </p:txBody>
+      </p:sp>
+      <p:sp>
+        <p:nvSpPr>
+          <p:cNvPr id="9" name="Rounded Rectangle 8"/>
+          <p:cNvSpPr/>
+          <p:nvPr/>
+        </p:nvSpPr>
+        <p:spPr>
+          <a:xfrm>
+            <a:off x="4370832" y="1536192"/>
+            <a:ext cx="3456432" cy="1133856"/>
+          </a:xfrm>
+          <a:prstGeom prst="roundRect">
+            <a:avLst/>
+          </a:prstGeom>
+          <a:solidFill>
+            <a:srgbClr val="131D32"/>
+          </a:solidFill>
+          <a:ln>
+            <a:noFill/>
+          </a:ln>
+        </p:spPr>
+        <p:style>
+          <a:lnRef idx="1">
+            <a:schemeClr val="accent1"/>
+          </a:lnRef>
+          <a:fillRef idx="3">
+            <a:schemeClr val="accent1"/>
+          </a:fillRef>
+          <a:effectRef idx="2">
+            <a:schemeClr val="accent1"/>
+          </a:effectRef>
+          <a:fontRef idx="minor">
+            <a:schemeClr val="lt1"/>
+          </a:fontRef>
+        </p:style>
+        <p:txBody>
+          <a:bodyPr rtlCol="0" anchor="ctr"/>
+          <a:lstStyle/>
+          <a:p>
+            <a:pPr algn="ctr"/>
+          </a:p>
+        </p:txBody>
+      </p:sp>
+      <p:sp>
+        <p:nvSpPr>
+          <p:cNvPr id="10" name="Rectangle 9"/>
+          <p:cNvSpPr/>
+          <p:nvPr/>
+        </p:nvSpPr>
+        <p:spPr>
+          <a:xfrm>
+            <a:off x="4370832" y="1600200"/>
+            <a:ext cx="50292" cy="1005840"/>
+          </a:xfrm>
+          <a:prstGeom prst="rect">
+            <a:avLst/>
+          </a:prstGeom>
+          <a:solidFill>
+            <a:srgbClr val="70A7FF"/>
+          </a:solidFill>
+          <a:ln>
+            <a:noFill/>
+          </a:ln>
+        </p:spPr>
+        <p:style>
+          <a:lnRef idx="1">
+            <a:schemeClr val="accent1"/>
+          </a:lnRef>
+          <a:fillRef idx="3">
+            <a:schemeClr val="accent1"/>
+          </a:fillRef>
+          <a:effectRef idx="2">
+            <a:schemeClr val="accent1"/>
+          </a:effectRef>
+          <a:fontRef idx="minor">
+            <a:schemeClr val="lt1"/>
+          </a:fontRef>
+        </p:style>
+        <p:txBody>
+          <a:bodyPr rtlCol="0" anchor="ctr"/>
+          <a:lstStyle/>
+          <a:p>
+            <a:pPr algn="ctr"/>
+          </a:p>
+        </p:txBody>
+      </p:sp>
+      <p:sp>
+        <p:nvSpPr>
+          <p:cNvPr id="11" name="TextBox 10"/>
+          <p:cNvSpPr txBox="1"/>
+          <p:nvPr/>
+        </p:nvSpPr>
+        <p:spPr>
+          <a:xfrm>
+            <a:off x="4526280" y="1600200"/>
+            <a:ext cx="3163824" cy="292608"/>
+          </a:xfrm>
+          <a:prstGeom prst="rect">
+            <a:avLst/>
+          </a:prstGeom>
+          <a:noFill/>
+        </p:spPr>
+        <p:txBody>
+          <a:bodyPr wrap="square" anchor="ctr" lIns="18288" rIns="18288" tIns="9144" bIns="9144">
+            <a:spAutoFit/>
+          </a:bodyPr>
+          <a:lstStyle/>
+          <a:p>
+            <a:pPr algn="l">
+              <a:spcBef>
+                <a:spcPts val="0"/>
+              </a:spcBef>
+              <a:spcAft>
+                <a:spcPts val="0"/>
+              </a:spcAft>
+            </a:pPr>
+            <a:r>
+              <a:rPr sz="1200" b="1">
+                <a:solidFill>
+                  <a:srgbClr val="F3F6FC"/>
+                </a:solidFill>
+                <a:latin typeface="Malgun Gothic"/>
+              </a:rPr>
+              <a:t>02  기존 APM과 차별점</a:t>
+            </a:r>
+          </a:p>
+        </p:txBody>
+      </p:sp>
+      <p:sp>
+        <p:nvSpPr>
+          <p:cNvPr id="12" name="TextBox 11"/>
+          <p:cNvSpPr txBox="1"/>
+          <p:nvPr/>
+        </p:nvSpPr>
+        <p:spPr>
+          <a:xfrm>
+            <a:off x="4526280" y="1929384"/>
+            <a:ext cx="3163824" cy="621792"/>
+          </a:xfrm>
+          <a:prstGeom prst="rect">
+            <a:avLst/>
+          </a:prstGeom>
+          <a:noFill/>
+        </p:spPr>
+        <p:txBody>
+          <a:bodyPr wrap="square" anchor="ctr" lIns="18288" rIns="18288" tIns="9144" bIns="9144">
+            <a:spAutoFit/>
+          </a:bodyPr>
+          <a:lstStyle/>
+          <a:p>
+            <a:pPr algn="l">
+              <a:spcBef>
+                <a:spcPts val="0"/>
+              </a:spcBef>
+              <a:spcAft>
+                <a:spcPts val="0"/>
+              </a:spcAft>
+            </a:pPr>
+            <a:r>
+              <a:rPr sz="960" b="0">
+                <a:solidFill>
+                  <a:srgbClr val="AAB7CC"/>
+                </a:solidFill>
+                <a:latin typeface="Malgun Gothic"/>
+              </a:rPr>
+              <a:t>기존 추적 기능과 겹치는 점, M-Trace가 더하는 가치는?</a:t>
+            </a:r>
+          </a:p>
+        </p:txBody>
+      </p:sp>
+      <p:sp>
+        <p:nvSpPr>
+          <p:cNvPr id="13" name="Rounded Rectangle 12"/>
+          <p:cNvSpPr/>
+          <p:nvPr/>
+        </p:nvSpPr>
+        <p:spPr>
+          <a:xfrm>
+            <a:off x="8119872" y="1536192"/>
+            <a:ext cx="3456432" cy="1133856"/>
+          </a:xfrm>
+          <a:prstGeom prst="roundRect">
+            <a:avLst/>
+          </a:prstGeom>
+          <a:solidFill>
+            <a:srgbClr val="131D32"/>
+          </a:solidFill>
+          <a:ln>
+            <a:noFill/>
+          </a:ln>
+        </p:spPr>
+        <p:style>
+          <a:lnRef idx="1">
+            <a:schemeClr val="accent1"/>
+          </a:lnRef>
+          <a:fillRef idx="3">
+            <a:schemeClr val="accent1"/>
+          </a:fillRef>
+          <a:effectRef idx="2">
+            <a:schemeClr val="accent1"/>
+          </a:effectRef>
+          <a:fontRef idx="minor">
+            <a:schemeClr val="lt1"/>
+          </a:fontRef>
+        </p:style>
+        <p:txBody>
+          <a:bodyPr rtlCol="0" anchor="ctr"/>
+          <a:lstStyle/>
+          <a:p>
+            <a:pPr algn="ctr"/>
+          </a:p>
+        </p:txBody>
+      </p:sp>
+      <p:sp>
+        <p:nvSpPr>
+          <p:cNvPr id="14" name="Rectangle 13"/>
+          <p:cNvSpPr/>
+          <p:nvPr/>
+        </p:nvSpPr>
+        <p:spPr>
+          <a:xfrm>
+            <a:off x="8119872" y="1600200"/>
+            <a:ext cx="50292" cy="1005840"/>
+          </a:xfrm>
+          <a:prstGeom prst="rect">
+            <a:avLst/>
+          </a:prstGeom>
+          <a:solidFill>
+            <a:srgbClr val="FFC36B"/>
+          </a:solidFill>
+          <a:ln>
+            <a:noFill/>
+          </a:ln>
+        </p:spPr>
+        <p:style>
+          <a:lnRef idx="1">
+            <a:schemeClr val="accent1"/>
+          </a:lnRef>
+          <a:fillRef idx="3">
+            <a:schemeClr val="accent1"/>
+          </a:fillRef>
+          <a:effectRef idx="2">
+            <a:schemeClr val="accent1"/>
+          </a:effectRef>
+          <a:fontRef idx="minor">
+            <a:schemeClr val="lt1"/>
+          </a:fontRef>
+        </p:style>
+        <p:txBody>
+          <a:bodyPr rtlCol="0" anchor="ctr"/>
+          <a:lstStyle/>
+          <a:p>
+            <a:pPr algn="ctr"/>
+          </a:p>
+        </p:txBody>
+      </p:sp>
+      <p:sp>
+        <p:nvSpPr>
+          <p:cNvPr id="15" name="TextBox 14"/>
+          <p:cNvSpPr txBox="1"/>
+          <p:nvPr/>
+        </p:nvSpPr>
+        <p:spPr>
+          <a:xfrm>
+            <a:off x="8275320" y="1600200"/>
+            <a:ext cx="3163824" cy="292608"/>
+          </a:xfrm>
+          <a:prstGeom prst="rect">
+            <a:avLst/>
+          </a:prstGeom>
+          <a:noFill/>
+        </p:spPr>
+        <p:txBody>
+          <a:bodyPr wrap="square" anchor="ctr" lIns="18288" rIns="18288" tIns="9144" bIns="9144">
+            <a:spAutoFit/>
+          </a:bodyPr>
+          <a:lstStyle/>
+          <a:p>
+            <a:pPr algn="l">
+              <a:spcBef>
+                <a:spcPts val="0"/>
+              </a:spcBef>
+              <a:spcAft>
+                <a:spcPts val="0"/>
+              </a:spcAft>
+            </a:pPr>
+            <a:r>
+              <a:rPr sz="1200" b="1">
+                <a:solidFill>
+                  <a:srgbClr val="F3F6FC"/>
+                </a:solidFill>
+                <a:latin typeface="Malgun Gothic"/>
+              </a:rPr>
+              <a:t>03  Trace ID 누락</a:t>
+            </a:r>
+          </a:p>
+        </p:txBody>
+      </p:sp>
+      <p:sp>
+        <p:nvSpPr>
+          <p:cNvPr id="16" name="TextBox 15"/>
+          <p:cNvSpPr txBox="1"/>
+          <p:nvPr/>
+        </p:nvSpPr>
+        <p:spPr>
+          <a:xfrm>
+            <a:off x="8275320" y="1929384"/>
+            <a:ext cx="3163824" cy="621792"/>
+          </a:xfrm>
+          <a:prstGeom prst="rect">
+            <a:avLst/>
+          </a:prstGeom>
+          <a:noFill/>
+        </p:spPr>
+        <p:txBody>
+          <a:bodyPr wrap="square" anchor="ctr" lIns="18288" rIns="18288" tIns="9144" bIns="9144">
+            <a:spAutoFit/>
+          </a:bodyPr>
+          <a:lstStyle/>
+          <a:p>
+            <a:pPr algn="l">
+              <a:spcBef>
+                <a:spcPts val="0"/>
+              </a:spcBef>
+              <a:spcAft>
+                <a:spcPts val="0"/>
+              </a:spcAft>
+            </a:pPr>
+            <a:r>
+              <a:rPr sz="960" b="0">
+                <a:solidFill>
+                  <a:srgbClr val="AAB7CC"/>
+                </a:solidFill>
+                <a:latin typeface="Malgun Gothic"/>
+              </a:rPr>
+              <a:t>전파 실패·누락·재발급 시 연결 결과를 어떻게 표시하나?</a:t>
+            </a:r>
+          </a:p>
+        </p:txBody>
+      </p:sp>
+      <p:sp>
+        <p:nvSpPr>
+          <p:cNvPr id="17" name="Rounded Rectangle 16"/>
+          <p:cNvSpPr/>
+          <p:nvPr/>
+        </p:nvSpPr>
+        <p:spPr>
+          <a:xfrm>
+            <a:off x="621792" y="2816352"/>
+            <a:ext cx="3456432" cy="1133856"/>
+          </a:xfrm>
+          <a:prstGeom prst="roundRect">
+            <a:avLst/>
+          </a:prstGeom>
+          <a:solidFill>
+            <a:srgbClr val="131D32"/>
+          </a:solidFill>
+          <a:ln>
+            <a:noFill/>
+          </a:ln>
+        </p:spPr>
+        <p:style>
+          <a:lnRef idx="1">
+            <a:schemeClr val="accent1"/>
+          </a:lnRef>
+          <a:fillRef idx="3">
+            <a:schemeClr val="accent1"/>
+          </a:fillRef>
+          <a:effectRef idx="2">
+            <a:schemeClr val="accent1"/>
+          </a:effectRef>
+          <a:fontRef idx="minor">
+            <a:schemeClr val="lt1"/>
+          </a:fontRef>
+        </p:style>
+        <p:txBody>
+          <a:bodyPr rtlCol="0" anchor="ctr"/>
+          <a:lstStyle/>
+          <a:p>
+            <a:pPr algn="ctr"/>
+          </a:p>
+        </p:txBody>
+      </p:sp>
+      <p:sp>
+        <p:nvSpPr>
+          <p:cNvPr id="18" name="Rectangle 17"/>
+          <p:cNvSpPr/>
+          <p:nvPr/>
+        </p:nvSpPr>
+        <p:spPr>
+          <a:xfrm>
+            <a:off x="621792" y="2880360"/>
+            <a:ext cx="50292" cy="1005840"/>
+          </a:xfrm>
+          <a:prstGeom prst="rect">
+            <a:avLst/>
+          </a:prstGeom>
+          <a:solidFill>
+            <a:srgbClr val="70A7FF"/>
+          </a:solidFill>
+          <a:ln>
+            <a:noFill/>
+          </a:ln>
+        </p:spPr>
+        <p:style>
+          <a:lnRef idx="1">
+            <a:schemeClr val="accent1"/>
+          </a:lnRef>
+          <a:fillRef idx="3">
+            <a:schemeClr val="accent1"/>
+          </a:fillRef>
+          <a:effectRef idx="2">
+            <a:schemeClr val="accent1"/>
+          </a:effectRef>
+          <a:fontRef idx="minor">
+            <a:schemeClr val="lt1"/>
+          </a:fontRef>
+        </p:style>
+        <p:txBody>
+          <a:bodyPr rtlCol="0" anchor="ctr"/>
+          <a:lstStyle/>
+          <a:p>
+            <a:pPr algn="ctr"/>
+          </a:p>
+        </p:txBody>
+      </p:sp>
+      <p:sp>
+        <p:nvSpPr>
+          <p:cNvPr id="19" name="TextBox 18"/>
+          <p:cNvSpPr txBox="1"/>
+          <p:nvPr/>
+        </p:nvSpPr>
+        <p:spPr>
+          <a:xfrm>
+            <a:off x="777240" y="2880360"/>
+            <a:ext cx="3163824" cy="292608"/>
+          </a:xfrm>
+          <a:prstGeom prst="rect">
+            <a:avLst/>
+          </a:prstGeom>
+          <a:noFill/>
+        </p:spPr>
+        <p:txBody>
+          <a:bodyPr wrap="square" anchor="ctr" lIns="18288" rIns="18288" tIns="9144" bIns="9144">
+            <a:spAutoFit/>
+          </a:bodyPr>
+          <a:lstStyle/>
+          <a:p>
+            <a:pPr algn="l">
+              <a:spcBef>
+                <a:spcPts val="0"/>
+              </a:spcBef>
+              <a:spcAft>
+                <a:spcPts val="0"/>
+              </a:spcAft>
+            </a:pPr>
+            <a:r>
+              <a:rPr sz="1200" b="1">
+                <a:solidFill>
+                  <a:srgbClr val="F3F6FC"/>
+                </a:solidFill>
+                <a:latin typeface="Malgun Gothic"/>
+              </a:rPr>
+              <a:t>04  고객 환경 다양성</a:t>
+            </a:r>
+          </a:p>
+        </p:txBody>
+      </p:sp>
+      <p:sp>
+        <p:nvSpPr>
+          <p:cNvPr id="20" name="TextBox 19"/>
+          <p:cNvSpPr txBox="1"/>
+          <p:nvPr/>
+        </p:nvSpPr>
+        <p:spPr>
+          <a:xfrm>
+            <a:off x="777240" y="3209544"/>
+            <a:ext cx="3163824" cy="621792"/>
+          </a:xfrm>
+          <a:prstGeom prst="rect">
+            <a:avLst/>
+          </a:prstGeom>
+          <a:noFill/>
+        </p:spPr>
+        <p:txBody>
+          <a:bodyPr wrap="square" anchor="ctr" lIns="18288" rIns="18288" tIns="9144" bIns="9144">
+            <a:spAutoFit/>
+          </a:bodyPr>
+          <a:lstStyle/>
+          <a:p>
+            <a:pPr algn="l">
+              <a:spcBef>
+                <a:spcPts val="0"/>
+              </a:spcBef>
+              <a:spcAft>
+                <a:spcPts val="0"/>
+              </a:spcAft>
+            </a:pPr>
+            <a:r>
+              <a:rPr sz="960" b="0">
+                <a:solidFill>
+                  <a:srgbClr val="AAB7CC"/>
+                </a:solidFill>
+                <a:latin typeface="Malgun Gothic"/>
+              </a:rPr>
+              <a:t>제품·버전·로그 차이를 어떤 범위의 어댑터로 지원하나?</a:t>
+            </a:r>
+          </a:p>
+        </p:txBody>
+      </p:sp>
+      <p:sp>
+        <p:nvSpPr>
+          <p:cNvPr id="21" name="Rounded Rectangle 20"/>
+          <p:cNvSpPr/>
+          <p:nvPr/>
+        </p:nvSpPr>
+        <p:spPr>
+          <a:xfrm>
+            <a:off x="4370832" y="2816352"/>
+            <a:ext cx="3456432" cy="1133856"/>
+          </a:xfrm>
+          <a:prstGeom prst="roundRect">
+            <a:avLst/>
+          </a:prstGeom>
+          <a:solidFill>
+            <a:srgbClr val="131D32"/>
+          </a:solidFill>
+          <a:ln>
+            <a:noFill/>
+          </a:ln>
+        </p:spPr>
+        <p:style>
+          <a:lnRef idx="1">
+            <a:schemeClr val="accent1"/>
+          </a:lnRef>
+          <a:fillRef idx="3">
+            <a:schemeClr val="accent1"/>
+          </a:fillRef>
+          <a:effectRef idx="2">
+            <a:schemeClr val="accent1"/>
+          </a:effectRef>
+          <a:fontRef idx="minor">
+            <a:schemeClr val="lt1"/>
+          </a:fontRef>
+        </p:style>
+        <p:txBody>
+          <a:bodyPr rtlCol="0" anchor="ctr"/>
+          <a:lstStyle/>
+          <a:p>
+            <a:pPr algn="ctr"/>
+          </a:p>
+        </p:txBody>
+      </p:sp>
+      <p:sp>
+        <p:nvSpPr>
+          <p:cNvPr id="22" name="Rectangle 21"/>
+          <p:cNvSpPr/>
+          <p:nvPr/>
+        </p:nvSpPr>
+        <p:spPr>
+          <a:xfrm>
+            <a:off x="4370832" y="2880360"/>
+            <a:ext cx="50292" cy="1005840"/>
+          </a:xfrm>
+          <a:prstGeom prst="rect">
+            <a:avLst/>
+          </a:prstGeom>
+          <a:solidFill>
+            <a:srgbClr val="42D6C1"/>
+          </a:solidFill>
+          <a:ln>
+            <a:noFill/>
+          </a:ln>
+        </p:spPr>
+        <p:style>
+          <a:lnRef idx="1">
+            <a:schemeClr val="accent1"/>
+          </a:lnRef>
+          <a:fillRef idx="3">
+            <a:schemeClr val="accent1"/>
+          </a:fillRef>
+          <a:effectRef idx="2">
+            <a:schemeClr val="accent1"/>
+          </a:effectRef>
+          <a:fontRef idx="minor">
+            <a:schemeClr val="lt1"/>
+          </a:fontRef>
+        </p:style>
+        <p:txBody>
+          <a:bodyPr rtlCol="0" anchor="ctr"/>
+          <a:lstStyle/>
+          <a:p>
+            <a:pPr algn="ctr"/>
+          </a:p>
+        </p:txBody>
+      </p:sp>
+      <p:sp>
+        <p:nvSpPr>
+          <p:cNvPr id="23" name="TextBox 22"/>
+          <p:cNvSpPr txBox="1"/>
+          <p:nvPr/>
+        </p:nvSpPr>
+        <p:spPr>
+          <a:xfrm>
+            <a:off x="4526280" y="2880360"/>
+            <a:ext cx="3163824" cy="292608"/>
+          </a:xfrm>
+          <a:prstGeom prst="rect">
+            <a:avLst/>
+          </a:prstGeom>
+          <a:noFill/>
+        </p:spPr>
+        <p:txBody>
+          <a:bodyPr wrap="square" anchor="ctr" lIns="18288" rIns="18288" tIns="9144" bIns="9144">
+            <a:spAutoFit/>
+          </a:bodyPr>
+          <a:lstStyle/>
+          <a:p>
+            <a:pPr algn="l">
+              <a:spcBef>
+                <a:spcPts val="0"/>
+              </a:spcBef>
+              <a:spcAft>
+                <a:spcPts val="0"/>
+              </a:spcAft>
+            </a:pPr>
+            <a:r>
+              <a:rPr sz="1200" b="1">
+                <a:solidFill>
+                  <a:srgbClr val="F3F6FC"/>
+                </a:solidFill>
+                <a:latin typeface="Malgun Gothic"/>
+              </a:rPr>
+              <a:t>05  Agent 운영 영향</a:t>
+            </a:r>
+          </a:p>
+        </p:txBody>
+      </p:sp>
+      <p:sp>
+        <p:nvSpPr>
+          <p:cNvPr id="24" name="TextBox 23"/>
+          <p:cNvSpPr txBox="1"/>
+          <p:nvPr/>
+        </p:nvSpPr>
+        <p:spPr>
+          <a:xfrm>
+            <a:off x="4526280" y="3209544"/>
+            <a:ext cx="3163824" cy="621792"/>
+          </a:xfrm>
+          <a:prstGeom prst="rect">
+            <a:avLst/>
+          </a:prstGeom>
+          <a:noFill/>
+        </p:spPr>
+        <p:txBody>
+          <a:bodyPr wrap="square" anchor="ctr" lIns="18288" rIns="18288" tIns="9144" bIns="9144">
+            <a:spAutoFit/>
+          </a:bodyPr>
+          <a:lstStyle/>
+          <a:p>
+            <a:pPr algn="l">
+              <a:spcBef>
+                <a:spcPts val="0"/>
+              </a:spcBef>
+              <a:spcAft>
+                <a:spcPts val="0"/>
+              </a:spcAft>
+            </a:pPr>
+            <a:r>
+              <a:rPr sz="960" b="0">
+                <a:solidFill>
+                  <a:srgbClr val="AAB7CC"/>
+                </a:solidFill>
+                <a:latin typeface="Malgun Gothic"/>
+              </a:rPr>
+              <a:t>CPU·메모리·디스크·네트워크 부하와 장애 시 영향은?</a:t>
+            </a:r>
+          </a:p>
+        </p:txBody>
+      </p:sp>
+      <p:sp>
+        <p:nvSpPr>
+          <p:cNvPr id="25" name="Rounded Rectangle 24"/>
+          <p:cNvSpPr/>
+          <p:nvPr/>
+        </p:nvSpPr>
+        <p:spPr>
+          <a:xfrm>
+            <a:off x="8119872" y="2816352"/>
+            <a:ext cx="3456432" cy="1133856"/>
+          </a:xfrm>
+          <a:prstGeom prst="roundRect">
+            <a:avLst/>
+          </a:prstGeom>
+          <a:solidFill>
+            <a:srgbClr val="131D32"/>
+          </a:solidFill>
+          <a:ln>
+            <a:noFill/>
+          </a:ln>
+        </p:spPr>
+        <p:style>
+          <a:lnRef idx="1">
+            <a:schemeClr val="accent1"/>
+          </a:lnRef>
+          <a:fillRef idx="3">
+            <a:schemeClr val="accent1"/>
+          </a:fillRef>
+          <a:effectRef idx="2">
+            <a:schemeClr val="accent1"/>
+          </a:effectRef>
+          <a:fontRef idx="minor">
+            <a:schemeClr val="lt1"/>
+          </a:fontRef>
+        </p:style>
+        <p:txBody>
+          <a:bodyPr rtlCol="0" anchor="ctr"/>
+          <a:lstStyle/>
+          <a:p>
+            <a:pPr algn="ctr"/>
+          </a:p>
+        </p:txBody>
+      </p:sp>
+      <p:sp>
+        <p:nvSpPr>
+          <p:cNvPr id="26" name="Rectangle 25"/>
+          <p:cNvSpPr/>
+          <p:nvPr/>
+        </p:nvSpPr>
+        <p:spPr>
+          <a:xfrm>
+            <a:off x="8119872" y="2880360"/>
+            <a:ext cx="50292" cy="1005840"/>
+          </a:xfrm>
+          <a:prstGeom prst="rect">
+            <a:avLst/>
+          </a:prstGeom>
+          <a:solidFill>
+            <a:srgbClr val="FFC36B"/>
+          </a:solidFill>
+          <a:ln>
+            <a:noFill/>
+          </a:ln>
+        </p:spPr>
+        <p:style>
+          <a:lnRef idx="1">
+            <a:schemeClr val="accent1"/>
+          </a:lnRef>
+          <a:fillRef idx="3">
+            <a:schemeClr val="accent1"/>
+          </a:fillRef>
+          <a:effectRef idx="2">
+            <a:schemeClr val="accent1"/>
+          </a:effectRef>
+          <a:fontRef idx="minor">
+            <a:schemeClr val="lt1"/>
+          </a:fontRef>
+        </p:style>
+        <p:txBody>
+          <a:bodyPr rtlCol="0" anchor="ctr"/>
+          <a:lstStyle/>
+          <a:p>
+            <a:pPr algn="ctr"/>
+          </a:p>
+        </p:txBody>
+      </p:sp>
+      <p:sp>
+        <p:nvSpPr>
+          <p:cNvPr id="27" name="TextBox 26"/>
+          <p:cNvSpPr txBox="1"/>
+          <p:nvPr/>
+        </p:nvSpPr>
+        <p:spPr>
+          <a:xfrm>
+            <a:off x="8275320" y="2880360"/>
+            <a:ext cx="3163824" cy="292608"/>
+          </a:xfrm>
+          <a:prstGeom prst="rect">
+            <a:avLst/>
+          </a:prstGeom>
+          <a:noFill/>
+        </p:spPr>
+        <p:txBody>
+          <a:bodyPr wrap="square" anchor="ctr" lIns="18288" rIns="18288" tIns="9144" bIns="9144">
+            <a:spAutoFit/>
+          </a:bodyPr>
+          <a:lstStyle/>
+          <a:p>
+            <a:pPr algn="l">
+              <a:spcBef>
+                <a:spcPts val="0"/>
+              </a:spcBef>
+              <a:spcAft>
+                <a:spcPts val="0"/>
+              </a:spcAft>
+            </a:pPr>
+            <a:r>
+              <a:rPr sz="1200" b="1">
+                <a:solidFill>
+                  <a:srgbClr val="F3F6FC"/>
+                </a:solidFill>
+                <a:latin typeface="Malgun Gothic"/>
+              </a:rPr>
+              <a:t>06  보안·데이터 관리</a:t>
+            </a:r>
+          </a:p>
+        </p:txBody>
+      </p:sp>
+      <p:sp>
+        <p:nvSpPr>
+          <p:cNvPr id="28" name="TextBox 27"/>
+          <p:cNvSpPr txBox="1"/>
+          <p:nvPr/>
+        </p:nvSpPr>
+        <p:spPr>
+          <a:xfrm>
+            <a:off x="8275320" y="3209544"/>
+            <a:ext cx="3163824" cy="621792"/>
+          </a:xfrm>
+          <a:prstGeom prst="rect">
+            <a:avLst/>
+          </a:prstGeom>
+          <a:noFill/>
+        </p:spPr>
+        <p:txBody>
+          <a:bodyPr wrap="square" anchor="ctr" lIns="18288" rIns="18288" tIns="9144" bIns="9144">
+            <a:spAutoFit/>
+          </a:bodyPr>
+          <a:lstStyle/>
+          <a:p>
+            <a:pPr algn="l">
+              <a:spcBef>
+                <a:spcPts val="0"/>
+              </a:spcBef>
+              <a:spcAft>
+                <a:spcPts val="0"/>
+              </a:spcAft>
+            </a:pPr>
+            <a:r>
+              <a:rPr sz="960" b="0">
+                <a:solidFill>
+                  <a:srgbClr val="AAB7CC"/>
+                </a:solidFill>
+                <a:latin typeface="Malgun Gothic"/>
+              </a:rPr>
+              <a:t>민감정보·암호화·접근권한·폐쇄망·보존/삭제 기준은?</a:t>
+            </a:r>
+          </a:p>
+        </p:txBody>
+      </p:sp>
+      <p:sp>
+        <p:nvSpPr>
+          <p:cNvPr id="29" name="Rounded Rectangle 28"/>
+          <p:cNvSpPr/>
+          <p:nvPr/>
+        </p:nvSpPr>
+        <p:spPr>
+          <a:xfrm>
+            <a:off x="621792" y="4096512"/>
+            <a:ext cx="3456432" cy="1133856"/>
+          </a:xfrm>
+          <a:prstGeom prst="roundRect">
+            <a:avLst/>
+          </a:prstGeom>
+          <a:solidFill>
+            <a:srgbClr val="131D32"/>
+          </a:solidFill>
+          <a:ln>
+            <a:noFill/>
+          </a:ln>
+        </p:spPr>
+        <p:style>
+          <a:lnRef idx="1">
+            <a:schemeClr val="accent1"/>
+          </a:lnRef>
+          <a:fillRef idx="3">
+            <a:schemeClr val="accent1"/>
+          </a:fillRef>
+          <a:effectRef idx="2">
+            <a:schemeClr val="accent1"/>
+          </a:effectRef>
+          <a:fontRef idx="minor">
+            <a:schemeClr val="lt1"/>
+          </a:fontRef>
+        </p:style>
+        <p:txBody>
+          <a:bodyPr rtlCol="0" anchor="ctr"/>
+          <a:lstStyle/>
+          <a:p>
+            <a:pPr algn="ctr"/>
+          </a:p>
+        </p:txBody>
+      </p:sp>
+      <p:sp>
+        <p:nvSpPr>
+          <p:cNvPr id="30" name="Rectangle 29"/>
+          <p:cNvSpPr/>
+          <p:nvPr/>
+        </p:nvSpPr>
+        <p:spPr>
+          <a:xfrm>
+            <a:off x="621792" y="4160520"/>
+            <a:ext cx="50292" cy="1005840"/>
+          </a:xfrm>
+          <a:prstGeom prst="rect">
+            <a:avLst/>
+          </a:prstGeom>
+          <a:solidFill>
+            <a:srgbClr val="FFC36B"/>
+          </a:solidFill>
+          <a:ln>
+            <a:noFill/>
+          </a:ln>
+        </p:spPr>
+        <p:style>
+          <a:lnRef idx="1">
+            <a:schemeClr val="accent1"/>
+          </a:lnRef>
+          <a:fillRef idx="3">
+            <a:schemeClr val="accent1"/>
+          </a:fillRef>
+          <a:effectRef idx="2">
+            <a:schemeClr val="accent1"/>
+          </a:effectRef>
+          <a:fontRef idx="minor">
+            <a:schemeClr val="lt1"/>
+          </a:fontRef>
+        </p:style>
+        <p:txBody>
+          <a:bodyPr rtlCol="0" anchor="ctr"/>
+          <a:lstStyle/>
+          <a:p>
+            <a:pPr algn="ctr"/>
+          </a:p>
+        </p:txBody>
+      </p:sp>
+      <p:sp>
+        <p:nvSpPr>
+          <p:cNvPr id="31" name="TextBox 30"/>
+          <p:cNvSpPr txBox="1"/>
+          <p:nvPr/>
+        </p:nvSpPr>
+        <p:spPr>
+          <a:xfrm>
+            <a:off x="777240" y="4160520"/>
+            <a:ext cx="3163824" cy="292608"/>
+          </a:xfrm>
+          <a:prstGeom prst="rect">
+            <a:avLst/>
+          </a:prstGeom>
+          <a:noFill/>
+        </p:spPr>
+        <p:txBody>
+          <a:bodyPr wrap="square" anchor="ctr" lIns="18288" rIns="18288" tIns="9144" bIns="9144">
+            <a:spAutoFit/>
+          </a:bodyPr>
+          <a:lstStyle/>
+          <a:p>
+            <a:pPr algn="l">
+              <a:spcBef>
+                <a:spcPts val="0"/>
+              </a:spcBef>
+              <a:spcAft>
+                <a:spcPts val="0"/>
+              </a:spcAft>
+            </a:pPr>
+            <a:r>
+              <a:rPr sz="1200" b="1">
+                <a:solidFill>
+                  <a:srgbClr val="F3F6FC"/>
+                </a:solidFill>
+                <a:latin typeface="Malgun Gothic"/>
+              </a:rPr>
+              <a:t>07  상관관계와 원인</a:t>
+            </a:r>
+          </a:p>
+        </p:txBody>
+      </p:sp>
+      <p:sp>
+        <p:nvSpPr>
+          <p:cNvPr id="32" name="TextBox 31"/>
+          <p:cNvSpPr txBox="1"/>
+          <p:nvPr/>
+        </p:nvSpPr>
+        <p:spPr>
+          <a:xfrm>
+            <a:off x="777240" y="4489704"/>
+            <a:ext cx="3163824" cy="621792"/>
+          </a:xfrm>
+          <a:prstGeom prst="rect">
+            <a:avLst/>
+          </a:prstGeom>
+          <a:noFill/>
+        </p:spPr>
+        <p:txBody>
+          <a:bodyPr wrap="square" anchor="ctr" lIns="18288" rIns="18288" tIns="9144" bIns="9144">
+            <a:spAutoFit/>
+          </a:bodyPr>
+          <a:lstStyle/>
+          <a:p>
+            <a:pPr algn="l">
+              <a:spcBef>
+                <a:spcPts val="0"/>
+              </a:spcBef>
+              <a:spcAft>
+                <a:spcPts val="0"/>
+              </a:spcAft>
+            </a:pPr>
+            <a:r>
+              <a:rPr sz="960" b="0">
+                <a:solidFill>
+                  <a:srgbClr val="AAB7CC"/>
+                </a:solidFill>
+                <a:latin typeface="Malgun Gothic"/>
+              </a:rPr>
+              <a:t>Trace ID 연결은 인과 증명이 아님. 후보 근거와 한계는?</a:t>
+            </a:r>
+          </a:p>
+        </p:txBody>
+      </p:sp>
+      <p:sp>
+        <p:nvSpPr>
+          <p:cNvPr id="33" name="Rounded Rectangle 32"/>
+          <p:cNvSpPr/>
+          <p:nvPr/>
+        </p:nvSpPr>
+        <p:spPr>
+          <a:xfrm>
+            <a:off x="4370832" y="4096512"/>
+            <a:ext cx="3456432" cy="1133856"/>
+          </a:xfrm>
+          <a:prstGeom prst="roundRect">
+            <a:avLst/>
+          </a:prstGeom>
+          <a:solidFill>
+            <a:srgbClr val="131D32"/>
+          </a:solidFill>
+          <a:ln>
+            <a:noFill/>
+          </a:ln>
+        </p:spPr>
+        <p:style>
+          <a:lnRef idx="1">
+            <a:schemeClr val="accent1"/>
+          </a:lnRef>
+          <a:fillRef idx="3">
+            <a:schemeClr val="accent1"/>
+          </a:fillRef>
+          <a:effectRef idx="2">
+            <a:schemeClr val="accent1"/>
+          </a:effectRef>
+          <a:fontRef idx="minor">
+            <a:schemeClr val="lt1"/>
+          </a:fontRef>
+        </p:style>
+        <p:txBody>
+          <a:bodyPr rtlCol="0" anchor="ctr"/>
+          <a:lstStyle/>
+          <a:p>
+            <a:pPr algn="ctr"/>
+          </a:p>
+        </p:txBody>
+      </p:sp>
+      <p:sp>
+        <p:nvSpPr>
+          <p:cNvPr id="34" name="Rectangle 33"/>
+          <p:cNvSpPr/>
+          <p:nvPr/>
+        </p:nvSpPr>
+        <p:spPr>
+          <a:xfrm>
+            <a:off x="4370832" y="4160520"/>
+            <a:ext cx="50292" cy="1005840"/>
+          </a:xfrm>
+          <a:prstGeom prst="rect">
+            <a:avLst/>
+          </a:prstGeom>
+          <a:solidFill>
+            <a:srgbClr val="42D6C1"/>
+          </a:solidFill>
+          <a:ln>
+            <a:noFill/>
+          </a:ln>
+        </p:spPr>
+        <p:style>
+          <a:lnRef idx="1">
+            <a:schemeClr val="accent1"/>
+          </a:lnRef>
+          <a:fillRef idx="3">
+            <a:schemeClr val="accent1"/>
+          </a:fillRef>
+          <a:effectRef idx="2">
+            <a:schemeClr val="accent1"/>
+          </a:effectRef>
+          <a:fontRef idx="minor">
+            <a:schemeClr val="lt1"/>
+          </a:fontRef>
+        </p:style>
+        <p:txBody>
+          <a:bodyPr rtlCol="0" anchor="ctr"/>
+          <a:lstStyle/>
+          <a:p>
+            <a:pPr algn="ctr"/>
+          </a:p>
+        </p:txBody>
+      </p:sp>
+      <p:sp>
+        <p:nvSpPr>
+          <p:cNvPr id="35" name="TextBox 34"/>
+          <p:cNvSpPr txBox="1"/>
+          <p:nvPr/>
+        </p:nvSpPr>
+        <p:spPr>
+          <a:xfrm>
+            <a:off x="4526280" y="4160520"/>
+            <a:ext cx="3163824" cy="292608"/>
+          </a:xfrm>
+          <a:prstGeom prst="rect">
+            <a:avLst/>
+          </a:prstGeom>
+          <a:noFill/>
+        </p:spPr>
+        <p:txBody>
+          <a:bodyPr wrap="square" anchor="ctr" lIns="18288" rIns="18288" tIns="9144" bIns="9144">
+            <a:spAutoFit/>
+          </a:bodyPr>
+          <a:lstStyle/>
+          <a:p>
+            <a:pPr algn="l">
+              <a:spcBef>
+                <a:spcPts val="0"/>
+              </a:spcBef>
+              <a:spcAft>
+                <a:spcPts val="0"/>
+              </a:spcAft>
+            </a:pPr>
+            <a:r>
+              <a:rPr sz="1200" b="1">
+                <a:solidFill>
+                  <a:srgbClr val="F3F6FC"/>
+                </a:solidFill>
+                <a:latin typeface="Malgun Gothic"/>
+              </a:rPr>
+              <a:t>08  효과·지불 의사</a:t>
+            </a:r>
+          </a:p>
+        </p:txBody>
+      </p:sp>
+      <p:sp>
+        <p:nvSpPr>
+          <p:cNvPr id="36" name="TextBox 35"/>
+          <p:cNvSpPr txBox="1"/>
+          <p:nvPr/>
+        </p:nvSpPr>
+        <p:spPr>
+          <a:xfrm>
+            <a:off x="4526280" y="4489704"/>
+            <a:ext cx="3163824" cy="621792"/>
+          </a:xfrm>
+          <a:prstGeom prst="rect">
+            <a:avLst/>
+          </a:prstGeom>
+          <a:noFill/>
+        </p:spPr>
+        <p:txBody>
+          <a:bodyPr wrap="square" anchor="ctr" lIns="18288" rIns="18288" tIns="9144" bIns="9144">
+            <a:spAutoFit/>
+          </a:bodyPr>
+          <a:lstStyle/>
+          <a:p>
+            <a:pPr algn="l">
+              <a:spcBef>
+                <a:spcPts val="0"/>
+              </a:spcBef>
+              <a:spcAft>
+                <a:spcPts val="0"/>
+              </a:spcAft>
+            </a:pPr>
+            <a:r>
+              <a:rPr sz="960" b="0">
+                <a:solidFill>
+                  <a:srgbClr val="AAB7CC"/>
+                </a:solidFill>
+                <a:latin typeface="Malgun Gothic"/>
+              </a:rPr>
+              <a:t>초동대응 시간·조사 노력 절감과 구매 의사를 어떻게 검증하나?</a:t>
+            </a:r>
+          </a:p>
+        </p:txBody>
+      </p:sp>
+      <p:sp>
+        <p:nvSpPr>
+          <p:cNvPr id="37" name="Rounded Rectangle 36"/>
+          <p:cNvSpPr/>
+          <p:nvPr/>
+        </p:nvSpPr>
+        <p:spPr>
+          <a:xfrm>
+            <a:off x="8119872" y="4096512"/>
+            <a:ext cx="3456432" cy="1133856"/>
+          </a:xfrm>
+          <a:prstGeom prst="roundRect">
+            <a:avLst/>
+          </a:prstGeom>
+          <a:solidFill>
+            <a:srgbClr val="131D32"/>
+          </a:solidFill>
+          <a:ln>
+            <a:noFill/>
+          </a:ln>
+        </p:spPr>
+        <p:style>
+          <a:lnRef idx="1">
+            <a:schemeClr val="accent1"/>
+          </a:lnRef>
+          <a:fillRef idx="3">
+            <a:schemeClr val="accent1"/>
+          </a:fillRef>
+          <a:effectRef idx="2">
+            <a:schemeClr val="accent1"/>
+          </a:effectRef>
+          <a:fontRef idx="minor">
+            <a:schemeClr val="lt1"/>
+          </a:fontRef>
+        </p:style>
+        <p:txBody>
+          <a:bodyPr rtlCol="0" anchor="ctr"/>
+          <a:lstStyle/>
+          <a:p>
+            <a:pPr algn="ctr"/>
+          </a:p>
+        </p:txBody>
+      </p:sp>
+      <p:sp>
+        <p:nvSpPr>
+          <p:cNvPr id="38" name="Rectangle 37"/>
+          <p:cNvSpPr/>
+          <p:nvPr/>
+        </p:nvSpPr>
+        <p:spPr>
+          <a:xfrm>
+            <a:off x="8119872" y="4160520"/>
+            <a:ext cx="50292" cy="1005840"/>
+          </a:xfrm>
+          <a:prstGeom prst="rect">
+            <a:avLst/>
+          </a:prstGeom>
+          <a:solidFill>
+            <a:srgbClr val="70A7FF"/>
+          </a:solidFill>
+          <a:ln>
+            <a:noFill/>
+          </a:ln>
+        </p:spPr>
+        <p:style>
+          <a:lnRef idx="1">
+            <a:schemeClr val="accent1"/>
+          </a:lnRef>
+          <a:fillRef idx="3">
+            <a:schemeClr val="accent1"/>
+          </a:fillRef>
+          <a:effectRef idx="2">
+            <a:schemeClr val="accent1"/>
+          </a:effectRef>
+          <a:fontRef idx="minor">
+            <a:schemeClr val="lt1"/>
+          </a:fontRef>
+        </p:style>
+        <p:txBody>
+          <a:bodyPr rtlCol="0" anchor="ctr"/>
+          <a:lstStyle/>
+          <a:p>
+            <a:pPr algn="ctr"/>
+          </a:p>
+        </p:txBody>
+      </p:sp>
+      <p:sp>
+        <p:nvSpPr>
+          <p:cNvPr id="39" name="TextBox 38"/>
+          <p:cNvSpPr txBox="1"/>
+          <p:nvPr/>
+        </p:nvSpPr>
+        <p:spPr>
+          <a:xfrm>
+            <a:off x="8275320" y="4160520"/>
+            <a:ext cx="3163824" cy="292608"/>
+          </a:xfrm>
+          <a:prstGeom prst="rect">
+            <a:avLst/>
+          </a:prstGeom>
+          <a:noFill/>
+        </p:spPr>
+        <p:txBody>
+          <a:bodyPr wrap="square" anchor="ctr" lIns="18288" rIns="18288" tIns="9144" bIns="9144">
+            <a:spAutoFit/>
+          </a:bodyPr>
+          <a:lstStyle/>
+          <a:p>
+            <a:pPr algn="l">
+              <a:spcBef>
+                <a:spcPts val="0"/>
+              </a:spcBef>
+              <a:spcAft>
+                <a:spcPts val="0"/>
+              </a:spcAft>
+            </a:pPr>
+            <a:r>
+              <a:rPr sz="1200" b="1">
+                <a:solidFill>
+                  <a:srgbClr val="F3F6FC"/>
+                </a:solidFill>
+                <a:latin typeface="Malgun Gothic"/>
+              </a:rPr>
+              <a:t>09  미충족 업무·적합성</a:t>
+            </a:r>
+          </a:p>
+        </p:txBody>
+      </p:sp>
+      <p:sp>
+        <p:nvSpPr>
+          <p:cNvPr id="40" name="TextBox 39"/>
+          <p:cNvSpPr txBox="1"/>
+          <p:nvPr/>
+        </p:nvSpPr>
+        <p:spPr>
+          <a:xfrm>
+            <a:off x="8275320" y="4489704"/>
+            <a:ext cx="3163824" cy="621792"/>
+          </a:xfrm>
+          <a:prstGeom prst="rect">
+            <a:avLst/>
+          </a:prstGeom>
+          <a:noFill/>
+        </p:spPr>
+        <p:txBody>
+          <a:bodyPr wrap="square" anchor="ctr" lIns="18288" rIns="18288" tIns="9144" bIns="9144">
+            <a:spAutoFit/>
+          </a:bodyPr>
+          <a:lstStyle/>
+          <a:p>
+            <a:pPr algn="l">
+              <a:spcBef>
+                <a:spcPts val="0"/>
+              </a:spcBef>
+              <a:spcAft>
+                <a:spcPts val="0"/>
+              </a:spcAft>
+            </a:pPr>
+            <a:r>
+              <a:rPr sz="960" b="0">
+                <a:solidFill>
+                  <a:srgbClr val="AAB7CC"/>
+                </a:solidFill>
+                <a:latin typeface="Malgun Gothic"/>
+              </a:rPr>
+              <a:t>기존 도구가 해결하지 못하는 구체 사례와 업무는 무엇인가?</a:t>
+            </a:r>
+          </a:p>
+        </p:txBody>
+      </p:sp>
+      <p:sp>
+        <p:nvSpPr>
+          <p:cNvPr id="41" name="Rounded Rectangle 40"/>
+          <p:cNvSpPr/>
+          <p:nvPr/>
+        </p:nvSpPr>
+        <p:spPr>
+          <a:xfrm>
+            <a:off x="621792" y="5431536"/>
+            <a:ext cx="10954512" cy="621792"/>
+          </a:xfrm>
+          <a:prstGeom prst="roundRect">
+            <a:avLst/>
+          </a:prstGeom>
+          <a:solidFill>
+            <a:srgbClr val="192640"/>
+          </a:solidFill>
+          <a:ln>
+            <a:noFill/>
+          </a:ln>
+        </p:spPr>
+        <p:style>
+          <a:lnRef idx="1">
+            <a:schemeClr val="accent1"/>
+          </a:lnRef>
+          <a:fillRef idx="3">
+            <a:schemeClr val="accent1"/>
+          </a:fillRef>
+          <a:effectRef idx="2">
+            <a:schemeClr val="accent1"/>
+          </a:effectRef>
+          <a:fontRef idx="minor">
+            <a:schemeClr val="lt1"/>
+          </a:fontRef>
+        </p:style>
+        <p:txBody>
+          <a:bodyPr rtlCol="0" anchor="ctr"/>
+          <a:lstStyle/>
+          <a:p>
+            <a:pPr algn="ctr"/>
+          </a:p>
+        </p:txBody>
+      </p:sp>
+      <p:sp>
+        <p:nvSpPr>
+          <p:cNvPr id="42" name="TextBox 41"/>
+          <p:cNvSpPr txBox="1"/>
+          <p:nvPr/>
+        </p:nvSpPr>
+        <p:spPr>
+          <a:xfrm>
+            <a:off x="859536" y="5495544"/>
+            <a:ext cx="10469880" cy="493776"/>
+          </a:xfrm>
+          <a:prstGeom prst="rect">
+            <a:avLst/>
+          </a:prstGeom>
+          <a:noFill/>
+        </p:spPr>
+        <p:txBody>
+          <a:bodyPr wrap="square" anchor="ctr" lIns="18288" rIns="18288" tIns="9144" bIns="9144">
+            <a:spAutoFit/>
+          </a:bodyPr>
+          <a:lstStyle/>
+          <a:p>
+            <a:pPr algn="l">
+              <a:spcBef>
+                <a:spcPts val="0"/>
+              </a:spcBef>
+              <a:spcAft>
+                <a:spcPts val="0"/>
+              </a:spcAft>
+            </a:pPr>
+            <a:r>
+              <a:rPr sz="1019" b="1">
+                <a:solidFill>
+                  <a:srgbClr val="FFC36B"/>
+                </a:solidFill>
+                <a:latin typeface="Malgun Gothic"/>
+              </a:rPr>
+              <a:t>답변 원칙  |  단정 대신 고객 환경별 연계 검증, 측정 가능한 효과, 명확한 지원 범위를 제시합니다.</a:t>
+            </a:r>
+          </a:p>
+        </p:txBody>
+      </p:sp>
+      <p:sp>
+        <p:nvSpPr>
+          <p:cNvPr id="43" name="TextBox 42"/>
+          <p:cNvSpPr txBox="1"/>
+          <p:nvPr/>
+        </p:nvSpPr>
+        <p:spPr>
+          <a:xfrm>
+            <a:off x="585216" y="6501384"/>
+            <a:ext cx="8869680" cy="182880"/>
+          </a:xfrm>
+          <a:prstGeom prst="rect">
+            <a:avLst/>
+          </a:prstGeom>
+          <a:noFill/>
+        </p:spPr>
+        <p:txBody>
+          <a:bodyPr wrap="square" anchor="ctr" lIns="18288" rIns="18288" tIns="9144" bIns="9144">
+            <a:spAutoFit/>
+          </a:bodyPr>
+          <a:lstStyle/>
+          <a:p>
+            <a:pPr algn="l">
+              <a:spcBef>
+                <a:spcPts val="0"/>
+              </a:spcBef>
+              <a:spcAft>
+                <a:spcPts val="0"/>
+              </a:spcAft>
+            </a:pPr>
+            <a:r>
+              <a:rPr sz="900" b="0">
+                <a:solidFill>
+                  <a:srgbClr val="AAB7CC"/>
+                </a:solidFill>
+                <a:latin typeface="Malgun Gothic"/>
+              </a:rPr>
+              <a:t>M-Trace  |  서비스 요청 흐름·장애 원인 추적 솔루션</a:t>
+            </a:r>
+          </a:p>
+        </p:txBody>
+      </p:sp>
+      <p:sp>
+        <p:nvSpPr>
+          <p:cNvPr id="44" name="TextBox 43"/>
+          <p:cNvSpPr txBox="1"/>
+          <p:nvPr/>
+        </p:nvSpPr>
+        <p:spPr>
+          <a:xfrm>
+            <a:off x="10168128" y="6483096"/>
+            <a:ext cx="1371600" cy="210312"/>
+          </a:xfrm>
+          <a:prstGeom prst="rect">
+            <a:avLst/>
+          </a:prstGeom>
+          <a:noFill/>
+        </p:spPr>
+        <p:txBody>
+          <a:bodyPr wrap="square" anchor="ctr" lIns="18288" rIns="18288" tIns="9144" bIns="9144">
+            <a:spAutoFit/>
+          </a:bodyPr>
+          <a:lstStyle/>
+          <a:p>
+            <a:pPr algn="r">
+              <a:spcBef>
+                <a:spcPts val="0"/>
+              </a:spcBef>
+              <a:spcAft>
+                <a:spcPts val="0"/>
+              </a:spcAft>
+            </a:pPr>
+            <a:r>
+              <a:rPr sz="900" b="0">
+                <a:solidFill>
+                  <a:srgbClr val="AAB7CC"/>
+                </a:solidFill>
+                <a:latin typeface="Malgun Gothic"/>
+              </a:rPr>
+              <a:t>11</a:t>
             </a:r>
           </a:p>
         </p:txBody>

</xml_diff>